<commit_message>
Deck: apply Raquel's slide notes, transparent Aurora, new problem facts
</commit_message>
<xml_diff>
--- a/docs/slides/aura-curativa-deck.pptx
+++ b/docs/slides/aura-curativa-deck.pptx
@@ -595,7 +595,7 @@
           <a:p>
             <a:r>
               <a:rPr lang="en-US" dirty="0"/>
-              <a:t>Who: patients in Puerto Rico who pay an out-of-network provider. Why: the reimbursement rules are spread across long policy documents, insurers pay their own rate minus copay, and the claim needs a form, a letter, and the provider's signature.</a:t>
+              <a:t>Who: patients in Puerto Rico who pay an out-of-network provider. The money is often there: every First Medical Directo plan pays back out-of-network visits, and even Triple-S's closed-network plans pay $20 a month toward acupuncture or massage. But the claim needs the right form, a letter, and seven details from the provider, before a deadline. So people pay the full cost or skip care.</a:t>
             </a:r>
             <a:endParaRPr lang="en-US" dirty="0"/>
           </a:p>
@@ -859,7 +859,7 @@
           <a:p>
             <a:r>
               <a:rPr lang="en-US" dirty="0"/>
-              <a:t>Research first: we turned each plan's reimbursement rules into TypeScript. Everything runs in the browser. pdf-lib fills Triple-S's form by field name and First Medical's flat scan by coordinates. A small EC2 instance with Caddy serves the static files. Simulated: demo data is synthetic, estimates are averages, and First Medical does not publish its fee schedule.</a:t>
+              <a:t>Research first: we turned each plan's reimbursement rules into TypeScript. Everything runs in the browser. pdf-lib fills Triple-S's form by field name and First Medical's flat scan by coordinates. A small EC2 instance with Caddy serves the static files. Limitations: two insurers so far, estimates are published averages, First Medical does not publish its fee schedule, and the patient still files the claim. Demo data is synthetic.</a:t>
             </a:r>
             <a:endParaRPr lang="en-US" dirty="0"/>
           </a:p>
@@ -947,7 +947,7 @@
           <a:p>
             <a:r>
               <a:rPr lang="en-US" dirty="0"/>
-              <a:t>Rollout: pilot with patient groups and clinics, then add the missing insurers, then the provider-facing flow. Future features: prescription forms, an English toggle, and deadline reminders. Close with the live link and thank the judges.</a:t>
+              <a:t>Rollout: first add the missing insurers, then more comprehensive plan comparisons, then the provider-facing flow. Future features: prescription refunds, an English toggle, and deadline reminders. Close with the live link and thank the judges.</a:t>
             </a:r>
             <a:endParaRPr lang="en-US" dirty="0"/>
           </a:p>
@@ -1682,8 +1682,8 @@
         </p:nvSpPr>
         <p:spPr>
           <a:xfrm>
-            <a:off x="548640" y="1143000"/>
-            <a:ext cx="4937760" cy="822960"/>
+            <a:off x="548640" y="1097280"/>
+            <a:ext cx="4754880" cy="292608"/>
           </a:xfrm>
           <a:prstGeom prst="rect">
             <a:avLst/>
@@ -1699,27 +1699,63 @@
               <a:buNone/>
             </a:pPr>
             <a:r>
-              <a:rPr lang="en-US" sz="4400" b="1" dirty="0">
+              <a:rPr lang="en-US" sz="1500" b="1" dirty="0">
+                <a:solidFill>
+                  <a:schemeClr val="accent2"/>
+                </a:solidFill>
+              </a:rPr>
+              <a:t>We help you answer one key question</a:t>
+            </a:r>
+            <a:endParaRPr lang="en-US" sz="1500" dirty="0"/>
+          </a:p>
+        </p:txBody>
+      </p:sp>
+      <p:sp>
+        <p:nvSpPr>
+          <p:cNvPr id="5" name="Text 2"/>
+          <p:cNvSpPr txBox="1"/>
+          <p:nvPr/>
+        </p:nvSpPr>
+        <p:spPr>
+          <a:xfrm>
+            <a:off x="548640" y="1389888"/>
+            <a:ext cx="4754880" cy="594360"/>
+          </a:xfrm>
+          <a:prstGeom prst="rect">
+            <a:avLst/>
+          </a:prstGeom>
+          <a:noFill/>
+          <a:ln/>
+        </p:spPr>
+        <p:txBody>
+          <a:bodyPr wrap="square" lIns="0" tIns="0" rIns="0" bIns="0" rtlCol="0" anchor="ctr"/>
+          <a:lstStyle/>
+          <a:p>
+            <a:pPr indent="0" marL="0">
+              <a:buNone/>
+            </a:pPr>
+            <a:r>
+              <a:rPr lang="en-US" sz="3400" b="1" dirty="0">
                 <a:solidFill>
                   <a:schemeClr val="tx2"/>
                 </a:solidFill>
               </a:rPr>
               <a:t>¿Me reembolsan?</a:t>
             </a:r>
-            <a:endParaRPr lang="en-US" sz="4400" dirty="0"/>
-          </a:p>
-        </p:txBody>
-      </p:sp>
-      <p:sp>
-        <p:nvSpPr>
-          <p:cNvPr id="5" name="Text 2"/>
-          <p:cNvSpPr txBox="1"/>
-          <p:nvPr/>
-        </p:nvSpPr>
-        <p:spPr>
-          <a:xfrm>
-            <a:off x="548640" y="1965960"/>
-            <a:ext cx="4572000" cy="685800"/>
+            <a:endParaRPr lang="en-US" sz="3400" dirty="0"/>
+          </a:p>
+        </p:txBody>
+      </p:sp>
+      <p:sp>
+        <p:nvSpPr>
+          <p:cNvPr id="6" name="Text 3"/>
+          <p:cNvSpPr txBox="1"/>
+          <p:nvPr/>
+        </p:nvSpPr>
+        <p:spPr>
+          <a:xfrm>
+            <a:off x="548640" y="2029968"/>
+            <a:ext cx="4572000" cy="640080"/>
           </a:xfrm>
           <a:prstGeom prst="rect">
             <a:avLst/>
@@ -1748,7 +1784,7 @@
       </p:sp>
       <p:sp>
         <p:nvSpPr>
-          <p:cNvPr id="6" name="team-0"/>
+          <p:cNvPr id="7" name="team-0"/>
           <p:cNvSpPr/>
           <p:nvPr/>
         </p:nvSpPr>
@@ -1782,7 +1818,7 @@
       </p:sp>
       <p:sp>
         <p:nvSpPr>
-          <p:cNvPr id="7" name="Text 4"/>
+          <p:cNvPr id="8" name="Text 5"/>
           <p:cNvSpPr txBox="1"/>
           <p:nvPr/>
         </p:nvSpPr>
@@ -1832,7 +1868,7 @@
       </p:sp>
       <p:sp>
         <p:nvSpPr>
-          <p:cNvPr id="8" name="team-1"/>
+          <p:cNvPr id="9" name="team-1"/>
           <p:cNvSpPr/>
           <p:nvPr/>
         </p:nvSpPr>
@@ -1866,7 +1902,7 @@
       </p:sp>
       <p:sp>
         <p:nvSpPr>
-          <p:cNvPr id="9" name="Text 6"/>
+          <p:cNvPr id="10" name="Text 7"/>
           <p:cNvSpPr txBox="1"/>
           <p:nvPr/>
         </p:nvSpPr>
@@ -1916,7 +1952,7 @@
       </p:sp>
       <p:sp>
         <p:nvSpPr>
-          <p:cNvPr id="10" name="team-2"/>
+          <p:cNvPr id="11" name="team-2"/>
           <p:cNvSpPr/>
           <p:nvPr/>
         </p:nvSpPr>
@@ -1950,7 +1986,7 @@
       </p:sp>
       <p:sp>
         <p:nvSpPr>
-          <p:cNvPr id="11" name="Text 8"/>
+          <p:cNvPr id="12" name="Text 9"/>
           <p:cNvSpPr txBox="1"/>
           <p:nvPr/>
         </p:nvSpPr>
@@ -2000,7 +2036,7 @@
       </p:sp>
       <p:sp>
         <p:nvSpPr>
-          <p:cNvPr id="12" name="Text 9"/>
+          <p:cNvPr id="13" name="Text 10"/>
           <p:cNvSpPr txBox="1"/>
           <p:nvPr/>
         </p:nvSpPr>
@@ -2036,7 +2072,7 @@
       </p:sp>
       <p:pic>
         <p:nvPicPr>
-          <p:cNvPr id="13" name="aurora-photo" descr="Aurora Borealis, the team cat">    </p:cNvPr>
+          <p:cNvPr id="14" name="aurora-photo" descr="Aurora Borealis, the team cat">    </p:cNvPr>
           <p:cNvPicPr>
             <a:picLocks noChangeAspect="1"/>
           </p:cNvPicPr>
@@ -2050,8 +2086,8 @@
         </p:blipFill>
         <p:spPr>
           <a:xfrm>
-            <a:off x="5486400" y="502920"/>
-            <a:ext cx="3154680" cy="4114800"/>
+            <a:off x="5257800" y="1526161"/>
+            <a:ext cx="3566160" cy="2908679"/>
           </a:xfrm>
           <a:prstGeom prst="rect">
             <a:avLst/>
@@ -2060,14 +2096,14 @@
       </p:pic>
       <p:sp>
         <p:nvSpPr>
-          <p:cNvPr id="14" name="Text 10"/>
-          <p:cNvSpPr txBox="1"/>
-          <p:nvPr/>
-        </p:nvSpPr>
-        <p:spPr>
-          <a:xfrm>
-            <a:off x="5486400" y="4690872"/>
-            <a:ext cx="3154680" cy="274320"/>
+          <p:cNvPr id="15" name="Text 11"/>
+          <p:cNvSpPr txBox="1"/>
+          <p:nvPr/>
+        </p:nvSpPr>
+        <p:spPr>
+          <a:xfrm>
+            <a:off x="5257800" y="4507992"/>
+            <a:ext cx="3566160" cy="274320"/>
           </a:xfrm>
           <a:prstGeom prst="rect">
             <a:avLst/>
@@ -2189,7 +2225,7 @@
                   <a:schemeClr val="tx2"/>
                 </a:solidFill>
               </a:rPr>
-              <a:t>Patients pay cash, then guess the refund</a:t>
+              <a:t>The refund is there. The paperwork stops people</a:t>
             </a:r>
             <a:endParaRPr lang="en-US" sz="2800" dirty="0"/>
           </a:p>
@@ -2296,7 +2332,7 @@
                   <a:schemeClr val="tx1"/>
                 </a:solidFill>
               </a:rPr>
-              <a:t>The rules hide in long policy documents. Many patients pay the full cost or skip care. Others file a claim that is returned or denied.</a:t>
+              <a:t>Many patients don't know their plan pays them back. Others give up on the form, the letter, and the provider's signature. So they pay the full cost or skip care.</a:t>
             </a:r>
             <a:endParaRPr lang="en-US" sz="1400" dirty="0"/>
           </a:p>
@@ -2333,7 +2369,7 @@
         <p:spPr>
           <a:xfrm>
             <a:off x="4553712" y="1371600"/>
-            <a:ext cx="1463040" cy="877824"/>
+            <a:ext cx="1600200" cy="877824"/>
           </a:xfrm>
           <a:prstGeom prst="rect">
             <a:avLst/>
@@ -2349,14 +2385,14 @@
               <a:buNone/>
             </a:pPr>
             <a:r>
-              <a:rPr lang="en-US" sz="2800" b="1" dirty="0">
+              <a:rPr lang="en-US" sz="2600" b="1" dirty="0">
                 <a:solidFill>
                   <a:schemeClr val="accent1"/>
                 </a:solidFill>
               </a:rPr>
-              <a:t>0 of 5</a:t>
-            </a:r>
-            <a:endParaRPr lang="en-US" sz="2800" dirty="0"/>
+              <a:t>4 of 4</a:t>
+            </a:r>
+            <a:endParaRPr lang="en-US" sz="2600" dirty="0"/>
           </a:p>
         </p:txBody>
       </p:sp>
@@ -2368,8 +2404,8 @@
         </p:nvSpPr>
         <p:spPr>
           <a:xfrm>
-            <a:off x="6035040" y="1371600"/>
-            <a:ext cx="2514600" cy="877824"/>
+            <a:off x="6217920" y="1371600"/>
+            <a:ext cx="2377440" cy="877824"/>
           </a:xfrm>
           <a:prstGeom prst="rect">
             <a:avLst/>
@@ -2385,14 +2421,14 @@
               <a:buNone/>
             </a:pPr>
             <a:r>
-              <a:rPr lang="en-US" sz="1200" dirty="0">
+              <a:rPr lang="en-US" sz="1100" dirty="0">
                 <a:solidFill>
                   <a:schemeClr val="tx1"/>
                 </a:solidFill>
               </a:rPr>
-              <a:t>Triple-S 2027 individual plans reimburse a routine out-of-network visit</a:t>
-            </a:r>
-            <a:endParaRPr lang="en-US" sz="1200" dirty="0"/>
+              <a:t>First Medical 2027 individual plans pay back out-of-network visits, at their top in-network rate minus copay</a:t>
+            </a:r>
+            <a:endParaRPr lang="en-US" sz="1100" dirty="0"/>
           </a:p>
         </p:txBody>
       </p:sp>
@@ -2427,7 +2463,7 @@
         <p:spPr>
           <a:xfrm>
             <a:off x="4553712" y="2395728"/>
-            <a:ext cx="1463040" cy="877824"/>
+            <a:ext cx="1600200" cy="877824"/>
           </a:xfrm>
           <a:prstGeom prst="rect">
             <a:avLst/>
@@ -2443,14 +2479,14 @@
               <a:buNone/>
             </a:pPr>
             <a:r>
-              <a:rPr lang="en-US" sz="2800" b="1" dirty="0">
+              <a:rPr lang="en-US" sz="2600" b="1" dirty="0">
                 <a:solidFill>
                   <a:schemeClr val="accent2"/>
                 </a:solidFill>
               </a:rPr>
-              <a:t>~$17</a:t>
-            </a:r>
-            <a:endParaRPr lang="en-US" sz="2800" dirty="0"/>
+              <a:t>$240/yr</a:t>
+            </a:r>
+            <a:endParaRPr lang="en-US" sz="2600" dirty="0"/>
           </a:p>
         </p:txBody>
       </p:sp>
@@ -2462,8 +2498,8 @@
         </p:nvSpPr>
         <p:spPr>
           <a:xfrm>
-            <a:off x="6035040" y="2395728"/>
-            <a:ext cx="2514600" cy="877824"/>
+            <a:off x="6217920" y="2395728"/>
+            <a:ext cx="2377440" cy="877824"/>
           </a:xfrm>
           <a:prstGeom prst="rect">
             <a:avLst/>
@@ -2479,14 +2515,14 @@
               <a:buNone/>
             </a:pPr>
             <a:r>
-              <a:rPr lang="en-US" sz="1200" dirty="0">
+              <a:rPr lang="en-US" sz="1100" dirty="0">
                 <a:solidFill>
                   <a:schemeClr val="tx1"/>
                 </a:solidFill>
               </a:rPr>
-              <a:t>Triple-S's published average back for a specialist visit, whatever you paid</a:t>
-            </a:r>
-            <a:endParaRPr lang="en-US" sz="1200" dirty="0"/>
+              <a:t>Triple-S Contigo Fit for acupuncture, massage or reflexology, even on closed-network plans</a:t>
+            </a:r>
+            <a:endParaRPr lang="en-US" sz="1100" dirty="0"/>
           </a:p>
         </p:txBody>
       </p:sp>
@@ -2521,7 +2557,7 @@
         <p:spPr>
           <a:xfrm>
             <a:off x="4553712" y="3419856"/>
-            <a:ext cx="1463040" cy="877824"/>
+            <a:ext cx="1600200" cy="877824"/>
           </a:xfrm>
           <a:prstGeom prst="rect">
             <a:avLst/>
@@ -2537,14 +2573,14 @@
               <a:buNone/>
             </a:pPr>
             <a:r>
-              <a:rPr lang="en-US" sz="2800" b="1" dirty="0">
+              <a:rPr lang="en-US" sz="2600" b="1" dirty="0">
                 <a:solidFill>
                   <a:schemeClr val="accent1"/>
                 </a:solidFill>
               </a:rPr>
-              <a:t>90 days</a:t>
-            </a:r>
-            <a:endParaRPr lang="en-US" sz="2800" dirty="0"/>
+              <a:t>7 details</a:t>
+            </a:r>
+            <a:endParaRPr lang="en-US" sz="2600" dirty="0"/>
           </a:p>
         </p:txBody>
       </p:sp>
@@ -2556,8 +2592,8 @@
         </p:nvSpPr>
         <p:spPr>
           <a:xfrm>
-            <a:off x="6035040" y="3419856"/>
-            <a:ext cx="2514600" cy="877824"/>
+            <a:off x="6217920" y="3419856"/>
+            <a:ext cx="2377440" cy="877824"/>
           </a:xfrm>
           <a:prstGeom prst="rect">
             <a:avLst/>
@@ -2573,14 +2609,14 @@
               <a:buNone/>
             </a:pPr>
             <a:r>
-              <a:rPr lang="en-US" sz="1200" dirty="0">
+              <a:rPr lang="en-US" sz="1100" dirty="0">
                 <a:solidFill>
                   <a:schemeClr val="tx1"/>
                 </a:solidFill>
               </a:rPr>
-              <a:t>to file with First Medical, which does reimburse out of network</a:t>
-            </a:r>
-            <a:endParaRPr lang="en-US" sz="1200" dirty="0"/>
+              <a:t>the claim needs from the provider, like NPI, diagnosis and CPT codes. First Medical gives 90 days to file</a:t>
+            </a:r>
+            <a:endParaRPr lang="en-US" sz="1100" dirty="0"/>
           </a:p>
         </p:txBody>
       </p:sp>
@@ -2614,7 +2650,7 @@
                   <a:srgbClr val="64748B"/>
                 </a:solidFill>
               </a:rPr>
-              <a:t>Sources: 2027 policies for 5 Triple-S and 4 First Medical individual plans. Triple-S out-of-network estimates published under Ley 134-2020.</a:t>
+              <a:t>Sources: 2027 policies for 5 Triple-S and 4 First Medical individual plans. Contigo Fit: $20/month, up to 12 months, on 4 of 5 Triple-S plans.</a:t>
             </a:r>
             <a:endParaRPr lang="en-US" sz="900" dirty="0"/>
           </a:p>
@@ -2760,7 +2796,7 @@
                   <a:schemeClr val="tx2"/>
                 </a:solidFill>
               </a:rPr>
-              <a:t>A straight answer, then a claim ready to file</a:t>
+              <a:t>A straight answer, and help filing the claim</a:t>
             </a:r>
             <a:endParaRPr lang="en-US" sz="2800" dirty="0"/>
           </a:p>
@@ -2783,7 +2819,7 @@
             </a:avLst>
           </a:prstGeom>
           <a:solidFill>
-            <a:srgbClr val="F0FDFA"/>
+            <a:srgbClr val="CCFBF1"/>
           </a:solidFill>
           <a:ln/>
         </p:spPr>
@@ -2871,7 +2907,7 @@
             <a:r>
               <a:rPr lang="en-US" sz="1300" b="1" dirty="0">
                 <a:solidFill>
-                  <a:schemeClr val="tx2"/>
+                  <a:srgbClr val="134E4A"/>
                 </a:solidFill>
               </a:rPr>
               <a:t>Pick your plan</a:t>
@@ -2933,7 +2969,7 @@
             </a:avLst>
           </a:prstGeom>
           <a:solidFill>
-            <a:srgbClr val="F0FDFA"/>
+            <a:srgbClr val="D1F5F3"/>
           </a:solidFill>
           <a:ln/>
         </p:spPr>
@@ -2953,7 +2989,7 @@
             <a:avLst/>
           </a:prstGeom>
           <a:solidFill>
-            <a:srgbClr val="0F766E"/>
+            <a:srgbClr val="256A87"/>
           </a:solidFill>
           <a:ln/>
         </p:spPr>
@@ -3021,7 +3057,7 @@
             <a:r>
               <a:rPr lang="en-US" sz="1300" b="1" dirty="0">
                 <a:solidFill>
-                  <a:schemeClr val="tx2"/>
+                  <a:srgbClr val="214560"/>
                 </a:solidFill>
               </a:rPr>
               <a:t>Pick your service</a:t>
@@ -3083,7 +3119,7 @@
             </a:avLst>
           </a:prstGeom>
           <a:solidFill>
-            <a:srgbClr val="EDE9FE"/>
+            <a:srgbClr val="D6EFF6"/>
           </a:solidFill>
           <a:ln/>
         </p:spPr>
@@ -3103,7 +3139,7 @@
             <a:avLst/>
           </a:prstGeom>
           <a:solidFill>
-            <a:srgbClr val="7C3AED"/>
+            <a:srgbClr val="3B5EA1"/>
           </a:solidFill>
           <a:ln/>
         </p:spPr>
@@ -3171,7 +3207,7 @@
             <a:r>
               <a:rPr lang="en-US" sz="1300" b="1" dirty="0">
                 <a:solidFill>
-                  <a:schemeClr val="accent2"/>
+                  <a:srgbClr val="303C75"/>
                 </a:solidFill>
               </a:rPr>
               <a:t>Get an answer</a:t>
@@ -3233,7 +3269,7 @@
             </a:avLst>
           </a:prstGeom>
           <a:solidFill>
-            <a:srgbClr val="EDE9FE"/>
+            <a:srgbClr val="DAE8F8"/>
           </a:solidFill>
           <a:ln/>
         </p:spPr>
@@ -3253,7 +3289,7 @@
             <a:avLst/>
           </a:prstGeom>
           <a:solidFill>
-            <a:srgbClr val="7C3AED"/>
+            <a:srgbClr val="5052BA"/>
           </a:solidFill>
           <a:ln/>
         </p:spPr>
@@ -3321,7 +3357,7 @@
             <a:r>
               <a:rPr lang="en-US" sz="1300" b="1" dirty="0">
                 <a:solidFill>
-                  <a:schemeClr val="accent2"/>
+                  <a:srgbClr val="3E338B"/>
                 </a:solidFill>
               </a:rPr>
               <a:t>Generate the claim</a:t>
@@ -3383,7 +3419,7 @@
             </a:avLst>
           </a:prstGeom>
           <a:solidFill>
-            <a:srgbClr val="F0FDFA"/>
+            <a:srgbClr val="DFE2FB"/>
           </a:solidFill>
           <a:ln/>
         </p:spPr>
@@ -3403,7 +3439,7 @@
             <a:avLst/>
           </a:prstGeom>
           <a:solidFill>
-            <a:srgbClr val="0F766E"/>
+            <a:srgbClr val="6646D4"/>
           </a:solidFill>
           <a:ln/>
         </p:spPr>
@@ -3471,7 +3507,7 @@
             <a:r>
               <a:rPr lang="en-US" sz="1300" b="1" dirty="0">
                 <a:solidFill>
-                  <a:schemeClr val="tx2"/>
+                  <a:srgbClr val="4D2AA0"/>
                 </a:solidFill>
               </a:rPr>
               <a:t>Send to provider</a:t>
@@ -3533,7 +3569,7 @@
             </a:avLst>
           </a:prstGeom>
           <a:solidFill>
-            <a:srgbClr val="F0FDFA"/>
+            <a:srgbClr val="E4DCFD"/>
           </a:solidFill>
           <a:ln/>
         </p:spPr>
@@ -3553,7 +3589,7 @@
             <a:avLst/>
           </a:prstGeom>
           <a:solidFill>
-            <a:srgbClr val="0F766E"/>
+            <a:srgbClr val="7C3AED"/>
           </a:solidFill>
           <a:ln/>
         </p:spPr>
@@ -3621,7 +3657,7 @@
             <a:r>
               <a:rPr lang="en-US" sz="1300" b="1" dirty="0">
                 <a:solidFill>
-                  <a:schemeClr val="tx2"/>
+                  <a:srgbClr val="5B21B6"/>
                 </a:solidFill>
               </a:rPr>
               <a:t>File it</a:t>
@@ -3983,7 +4019,7 @@
                   <a:schemeClr val="tx1"/>
                 </a:solidFill>
               </a:rPr>
-              <a:t>First Medical Silver, specialist visit: yes, with the rule and a $0 option</a:t>
+              <a:t>Yes or no, what the guidelines are, and your best alternative</a:t>
             </a:r>
             <a:endParaRPr lang="en-US" sz="1100" dirty="0"/>
           </a:p>
@@ -4086,7 +4122,7 @@
                   <a:schemeClr val="tx1"/>
                 </a:solidFill>
               </a:rPr>
-              <a:t>Filled field by field. The provider's section stays blank</a:t>
+              <a:t>Filled field by field. The provider's section is the only part that stays blank</a:t>
             </a:r>
             <a:endParaRPr lang="en-US" sz="1100" dirty="0"/>
           </a:p>
@@ -4189,7 +4225,7 @@
                   <a:schemeClr val="tx1"/>
                 </a:solidFill>
               </a:rPr>
-              <a:t>Prefilled email plus the next steps to file</a:t>
+              <a:t>Prefilled email or easy-to-print packet, plus the next steps to file</a:t>
             </a:r>
             <a:endParaRPr lang="en-US" sz="1100" dirty="0"/>
           </a:p>
@@ -4371,7 +4407,7 @@
                   <a:schemeClr val="tx2"/>
                 </a:solidFill>
               </a:rPr>
-              <a:t>How it works, and what remains simulated</a:t>
+              <a:t>How it works, and its current limitations</a:t>
             </a:r>
             <a:endParaRPr lang="en-US" sz="2800" dirty="0"/>
           </a:p>
@@ -4442,7 +4478,7 @@
         <p:spPr>
           <a:xfrm>
             <a:off x="960120" y="1371600"/>
-            <a:ext cx="2926080" cy="566928"/>
+            <a:ext cx="2834640" cy="566928"/>
           </a:xfrm>
           <a:prstGeom prst="rect">
             <a:avLst/>
@@ -4548,7 +4584,7 @@
         <p:spPr>
           <a:xfrm>
             <a:off x="960120" y="2139696"/>
-            <a:ext cx="2926080" cy="566928"/>
+            <a:ext cx="2834640" cy="566928"/>
           </a:xfrm>
           <a:prstGeom prst="rect">
             <a:avLst/>
@@ -4654,7 +4690,7 @@
         <p:spPr>
           <a:xfrm>
             <a:off x="960120" y="2907792"/>
-            <a:ext cx="2926080" cy="566928"/>
+            <a:ext cx="2834640" cy="566928"/>
           </a:xfrm>
           <a:prstGeom prst="rect">
             <a:avLst/>
@@ -4760,7 +4796,7 @@
         <p:spPr>
           <a:xfrm>
             <a:off x="960120" y="3675888"/>
-            <a:ext cx="2926080" cy="566928"/>
+            <a:ext cx="2834640" cy="566928"/>
           </a:xfrm>
           <a:prstGeom prst="rect">
             <a:avLst/>
@@ -4803,18 +4839,18 @@
       </p:sp>
       <p:sp>
         <p:nvSpPr>
-          <p:cNvPr id="16" name="col-real"/>
+          <p:cNvPr id="16" name="col-mvp"/>
           <p:cNvSpPr/>
           <p:nvPr/>
         </p:nvSpPr>
         <p:spPr>
           <a:xfrm>
-            <a:off x="4160520" y="1371600"/>
-            <a:ext cx="2240280" cy="3017520"/>
+            <a:off x="4069080" y="1371600"/>
+            <a:ext cx="2377440" cy="3017520"/>
           </a:xfrm>
           <a:prstGeom prst="roundRect">
             <a:avLst>
-              <a:gd name="adj" fmla="val 4898"/>
+              <a:gd name="adj" fmla="val 4615"/>
             </a:avLst>
           </a:prstGeom>
           <a:solidFill>
@@ -4831,7 +4867,7 @@
         </p:nvSpPr>
         <p:spPr>
           <a:xfrm>
-            <a:off x="4325112" y="1481328"/>
+            <a:off x="4233672" y="1481328"/>
             <a:ext cx="1920240" cy="329184"/>
           </a:xfrm>
           <a:prstGeom prst="rect">
@@ -4853,7 +4889,7 @@
                   <a:schemeClr val="accent1"/>
                 </a:solidFill>
               </a:rPr>
-              <a:t>Real</a:t>
+              <a:t>MVP</a:t>
             </a:r>
             <a:endParaRPr lang="en-US" sz="1500" dirty="0"/>
           </a:p>
@@ -4867,8 +4903,8 @@
         </p:nvSpPr>
         <p:spPr>
           <a:xfrm>
-            <a:off x="4270248" y="1874520"/>
-            <a:ext cx="2011680" cy="2423160"/>
+            <a:off x="4178808" y="1874520"/>
+            <a:ext cx="2148840" cy="2423160"/>
           </a:xfrm>
           <a:prstGeom prst="rect">
             <a:avLst/>
@@ -4893,7 +4929,7 @@
                   <a:schemeClr val="tx1"/>
                 </a:solidFill>
               </a:rPr>
-              <a:t>Rules from 5 Triple-S and 4 First Medical 2027 plans</a:t>
+              <a:t>Comprehensive analysis of Triple-S and First Medical's 2027 individual plans</a:t>
             </a:r>
             <a:endParaRPr lang="en-US" sz="1100" dirty="0"/>
           </a:p>
@@ -4911,7 +4947,7 @@
                   <a:schemeClr val="tx1"/>
                 </a:solidFill>
               </a:rPr>
-              <a:t>Triple-S's official form, filled by its real field names</a:t>
+              <a:t>Official insurance forms, filled out automatically</a:t>
             </a:r>
             <a:endParaRPr lang="en-US" sz="1100" dirty="0"/>
           </a:p>
@@ -4929,7 +4965,7 @@
                   <a:schemeClr val="tx1"/>
                 </a:solidFill>
               </a:rPr>
-              <a:t>First Medical's scanned form, placed by coordinates</a:t>
+              <a:t>Prewritten letter with a detailed explanation justifying reimbursement</a:t>
             </a:r>
             <a:endParaRPr lang="en-US" sz="1100" dirty="0"/>
           </a:p>
@@ -4965,7 +5001,7 @@
                   <a:schemeClr val="tx1"/>
                 </a:solidFill>
               </a:rPr>
-              <a:t>Vitest and Playwright tests, desktop and phone</a:t>
+              <a:t>Runs locally, and is public, free and open source</a:t>
             </a:r>
             <a:endParaRPr lang="en-US" sz="1100" dirty="0"/>
           </a:p>
@@ -4973,18 +5009,18 @@
       </p:sp>
       <p:sp>
         <p:nvSpPr>
-          <p:cNvPr id="19" name="col-sim"/>
+          <p:cNvPr id="19" name="col-limits"/>
           <p:cNvSpPr/>
           <p:nvPr/>
         </p:nvSpPr>
         <p:spPr>
           <a:xfrm>
-            <a:off x="6446520" y="1371600"/>
-            <a:ext cx="2240280" cy="3017520"/>
+            <a:off x="6583680" y="1371600"/>
+            <a:ext cx="2103120" cy="3017520"/>
           </a:xfrm>
           <a:prstGeom prst="roundRect">
             <a:avLst>
-              <a:gd name="adj" fmla="val 4898"/>
+              <a:gd name="adj" fmla="val 5217"/>
             </a:avLst>
           </a:prstGeom>
           <a:solidFill>
@@ -5001,7 +5037,7 @@
         </p:nvSpPr>
         <p:spPr>
           <a:xfrm>
-            <a:off x="6611112" y="1481328"/>
+            <a:off x="6748272" y="1481328"/>
             <a:ext cx="1920240" cy="329184"/>
           </a:xfrm>
           <a:prstGeom prst="rect">
@@ -5023,7 +5059,7 @@
                   <a:schemeClr val="accent2"/>
                 </a:solidFill>
               </a:rPr>
-              <a:t>Simulated or limited</a:t>
+              <a:t>Current limitations</a:t>
             </a:r>
             <a:endParaRPr lang="en-US" sz="1500" dirty="0"/>
           </a:p>
@@ -5037,8 +5073,8 @@
         </p:nvSpPr>
         <p:spPr>
           <a:xfrm>
-            <a:off x="6556248" y="1874520"/>
-            <a:ext cx="2011680" cy="2423160"/>
+            <a:off x="6693408" y="1874520"/>
+            <a:ext cx="1874520" cy="2423160"/>
           </a:xfrm>
           <a:prstGeom prst="rect">
             <a:avLst/>
@@ -5063,7 +5099,7 @@
                   <a:schemeClr val="tx1"/>
                 </a:solidFill>
               </a:rPr>
-              <a:t>Demo patient and provider data is synthetic</a:t>
+              <a:t>Two insurers so far, individual plans only</a:t>
             </a:r>
             <a:endParaRPr lang="en-US" sz="1100" dirty="0"/>
           </a:p>
@@ -5099,7 +5135,7 @@
                   <a:schemeClr val="tx1"/>
                 </a:solidFill>
               </a:rPr>
-              <a:t>First Medical: formula and copay, no dollar figure</a:t>
+              <a:t>First Medical doesn't publish its rates, so no dollar figure</a:t>
             </a:r>
             <a:endParaRPr lang="en-US" sz="1100" dirty="0"/>
           </a:p>
@@ -5117,7 +5153,7 @@
                   <a:schemeClr val="tx1"/>
                 </a:solidFill>
               </a:rPr>
-              <a:t>Patient still mails or emails the claim</a:t>
+              <a:t>The patient still mails or emails the claim</a:t>
             </a:r>
             <a:endParaRPr lang="en-US" sz="1100" dirty="0"/>
           </a:p>
@@ -5135,7 +5171,7 @@
                   <a:schemeClr val="tx1"/>
                 </a:solidFill>
               </a:rPr>
-              <a:t>Two insurers, individual plans only</a:t>
+              <a:t>No provider-side flow yet</a:t>
             </a:r>
             <a:endParaRPr lang="en-US" sz="1100" dirty="0"/>
           </a:p>
@@ -5375,7 +5411,7 @@
                   <a:schemeClr val="tx2"/>
                 </a:solidFill>
               </a:rPr>
-              <a:t>Pilot</a:t>
+              <a:t>More insurers</a:t>
             </a:r>
             <a:endParaRPr lang="en-US" sz="1800" dirty="0"/>
           </a:p>
@@ -5411,7 +5447,7 @@
                   <a:schemeClr val="tx1"/>
                 </a:solidFill>
               </a:rPr>
-              <a:t>Patient groups and integrative clinics in Puerto Rico. Check the rules with each insurer.</a:t>
+              <a:t>MCS, Plan de Salud Menonita, and the rest of the Puerto Rico market.</a:t>
             </a:r>
             <a:endParaRPr lang="en-US" sz="1200" dirty="0"/>
           </a:p>
@@ -5541,7 +5577,7 @@
                   <a:schemeClr val="tx2"/>
                 </a:solidFill>
               </a:rPr>
-              <a:t>More insurers</a:t>
+              <a:t>Plan comparisons</a:t>
             </a:r>
             <a:endParaRPr lang="en-US" sz="1800" dirty="0"/>
           </a:p>
@@ -5577,7 +5613,7 @@
                   <a:schemeClr val="tx1"/>
                 </a:solidFill>
               </a:rPr>
-              <a:t>MCS, Plan de Salud Menonita, and the rest of the Puerto Rico market.</a:t>
+              <a:t>More comprehensive side-by-side comparisons of plans, benefits and out-of-network coverage.</a:t>
             </a:r>
             <a:endParaRPr lang="en-US" sz="1200" dirty="0"/>
           </a:p>
@@ -5837,7 +5873,7 @@
                   <a:schemeClr val="accent2"/>
                 </a:solidFill>
               </a:rPr>
-              <a:t>Prescription forms</a:t>
+              <a:t>Prescription refunds</a:t>
             </a:r>
             <a:endParaRPr lang="en-US" sz="1100" dirty="0"/>
           </a:p>

</xml_diff>

<commit_message>
Point the live demo at auracurativa.pages.dev; note Cloudflare Pages hosting in the README
</commit_message>
<xml_diff>
--- a/docs/slides/aura-curativa-deck.pptx
+++ b/docs/slides/aura-curativa-deck.pptx
@@ -771,7 +771,7 @@
           <a:p>
             <a:r>
               <a:rPr lang="en-US" dirty="0"/>
-              <a:t>Live demo on 18-212-154-202.sslip.io. Pick First Medical, Directo Silver 2027, specialist visit. Show the answer and the cheaper option. Click ¡Empecemos!, fill the visit details, and show the generated packet: cover sheet, filled form, policy letter. Finish on the prefilled email to the provider. If the network fails, use the backup video.</a:t>
+              <a:t>Live demo on auracurativa.pages.dev. Pick First Medical, Directo Silver 2027, specialist visit. Show the answer and the cheaper option. Click ¡Empecemos!, fill the visit details, and show the generated packet: cover sheet, filled form, policy letter. Finish on the prefilled email to the provider. If the network fails, use the backup video.</a:t>
             </a:r>
             <a:endParaRPr lang="en-US" dirty="0"/>
           </a:p>
@@ -4261,7 +4261,7 @@
                   <a:schemeClr val="accent1"/>
                 </a:solidFill>
               </a:rPr>
-              <a:t>Live: 18-212-154-202.sslip.io</a:t>
+              <a:t>Live: auracurativa.pages.dev</a:t>
             </a:r>
             <a:endParaRPr lang="en-US" sz="1000" dirty="0"/>
           </a:p>
@@ -6036,7 +6036,7 @@
                   <a:schemeClr val="accent1"/>
                 </a:solidFill>
               </a:rPr>
-              <a:t>18-212-154-202.sslip.io</a:t>
+              <a:t>auracurativa.pages.dev</a:t>
             </a:r>
             <a:endParaRPr lang="en-US" sz="1100" dirty="0"/>
           </a:p>

</xml_diff>